<commit_message>
Fix misleading CMIP5 sentence in supplement thermosteric section
Clarify that only tau_d is fixed at the CMIP5 multi-model mean,
not that the model is fitted to CMIP5 output.

Co-Authored-By: Claude Opus 4.6 (1M context) <noreply@anthropic.com>
</commit_message>
<xml_diff>
--- a/slr_forecast/manuscripts/00_ddpi_slrforecast2026/v0/slr_forecast.pptx
+++ b/slr_forecast/manuscripts/00_ddpi_slrforecast2026/v0/slr_forecast.pptx
@@ -243,7 +243,7 @@
           <a:p>
             <a:fld id="{6635585C-8BC0-3044-9411-7D4DD7AD845D}" type="datetimeFigureOut">
               <a:rPr lang="en-US" smtClean="0"/>
-              <a:t>6/3/26</a:t>
+              <a:t>6/4/26</a:t>
             </a:fld>
             <a:endParaRPr lang="en-US"/>
           </a:p>
@@ -413,7 +413,7 @@
           <a:p>
             <a:fld id="{6635585C-8BC0-3044-9411-7D4DD7AD845D}" type="datetimeFigureOut">
               <a:rPr lang="en-US" smtClean="0"/>
-              <a:t>6/3/26</a:t>
+              <a:t>6/4/26</a:t>
             </a:fld>
             <a:endParaRPr lang="en-US"/>
           </a:p>
@@ -593,7 +593,7 @@
           <a:p>
             <a:fld id="{6635585C-8BC0-3044-9411-7D4DD7AD845D}" type="datetimeFigureOut">
               <a:rPr lang="en-US" smtClean="0"/>
-              <a:t>6/3/26</a:t>
+              <a:t>6/4/26</a:t>
             </a:fld>
             <a:endParaRPr lang="en-US"/>
           </a:p>
@@ -763,7 +763,7 @@
           <a:p>
             <a:fld id="{6635585C-8BC0-3044-9411-7D4DD7AD845D}" type="datetimeFigureOut">
               <a:rPr lang="en-US" smtClean="0"/>
-              <a:t>6/3/26</a:t>
+              <a:t>6/4/26</a:t>
             </a:fld>
             <a:endParaRPr lang="en-US"/>
           </a:p>
@@ -1009,7 +1009,7 @@
           <a:p>
             <a:fld id="{6635585C-8BC0-3044-9411-7D4DD7AD845D}" type="datetimeFigureOut">
               <a:rPr lang="en-US" smtClean="0"/>
-              <a:t>6/3/26</a:t>
+              <a:t>6/4/26</a:t>
             </a:fld>
             <a:endParaRPr lang="en-US"/>
           </a:p>
@@ -1241,7 +1241,7 @@
           <a:p>
             <a:fld id="{6635585C-8BC0-3044-9411-7D4DD7AD845D}" type="datetimeFigureOut">
               <a:rPr lang="en-US" smtClean="0"/>
-              <a:t>6/3/26</a:t>
+              <a:t>6/4/26</a:t>
             </a:fld>
             <a:endParaRPr lang="en-US"/>
           </a:p>
@@ -1608,7 +1608,7 @@
           <a:p>
             <a:fld id="{6635585C-8BC0-3044-9411-7D4DD7AD845D}" type="datetimeFigureOut">
               <a:rPr lang="en-US" smtClean="0"/>
-              <a:t>6/3/26</a:t>
+              <a:t>6/4/26</a:t>
             </a:fld>
             <a:endParaRPr lang="en-US"/>
           </a:p>
@@ -1726,7 +1726,7 @@
           <a:p>
             <a:fld id="{6635585C-8BC0-3044-9411-7D4DD7AD845D}" type="datetimeFigureOut">
               <a:rPr lang="en-US" smtClean="0"/>
-              <a:t>6/3/26</a:t>
+              <a:t>6/4/26</a:t>
             </a:fld>
             <a:endParaRPr lang="en-US"/>
           </a:p>
@@ -1821,7 +1821,7 @@
           <a:p>
             <a:fld id="{6635585C-8BC0-3044-9411-7D4DD7AD845D}" type="datetimeFigureOut">
               <a:rPr lang="en-US" smtClean="0"/>
-              <a:t>6/3/26</a:t>
+              <a:t>6/4/26</a:t>
             </a:fld>
             <a:endParaRPr lang="en-US"/>
           </a:p>
@@ -2098,7 +2098,7 @@
           <a:p>
             <a:fld id="{6635585C-8BC0-3044-9411-7D4DD7AD845D}" type="datetimeFigureOut">
               <a:rPr lang="en-US" smtClean="0"/>
-              <a:t>6/3/26</a:t>
+              <a:t>6/4/26</a:t>
             </a:fld>
             <a:endParaRPr lang="en-US"/>
           </a:p>
@@ -2355,7 +2355,7 @@
           <a:p>
             <a:fld id="{6635585C-8BC0-3044-9411-7D4DD7AD845D}" type="datetimeFigureOut">
               <a:rPr lang="en-US" smtClean="0"/>
-              <a:t>6/3/26</a:t>
+              <a:t>6/4/26</a:t>
             </a:fld>
             <a:endParaRPr lang="en-US"/>
           </a:p>
@@ -2568,7 +2568,7 @@
           <a:p>
             <a:fld id="{6635585C-8BC0-3044-9411-7D4DD7AD845D}" type="datetimeFigureOut">
               <a:rPr lang="en-US" smtClean="0"/>
-              <a:t>6/3/26</a:t>
+              <a:t>6/4/26</a:t>
             </a:fld>
             <a:endParaRPr lang="en-US"/>
           </a:p>
@@ -3101,8 +3101,8 @@
         </p:blipFill>
         <p:spPr>
           <a:xfrm>
-            <a:off x="1828800" y="7424985"/>
-            <a:ext cx="12502507" cy="10761416"/>
+            <a:off x="696693" y="21188019"/>
+            <a:ext cx="13188836" cy="11352166"/>
           </a:xfrm>
           <a:prstGeom prst="rect">
             <a:avLst/>
@@ -3131,7 +3131,7 @@
         </p:blipFill>
         <p:spPr>
           <a:xfrm>
-            <a:off x="16882439" y="7424985"/>
+            <a:off x="28914302" y="7048989"/>
             <a:ext cx="11912600" cy="15603470"/>
           </a:xfrm>
           <a:prstGeom prst="rect">
@@ -3161,8 +3161,8 @@
         </p:blipFill>
         <p:spPr>
           <a:xfrm>
-            <a:off x="1828800" y="20050252"/>
-            <a:ext cx="12355814" cy="11358863"/>
+            <a:off x="14020587" y="7142637"/>
+            <a:ext cx="13903327" cy="12781512"/>
           </a:xfrm>
           <a:prstGeom prst="rect">
             <a:avLst/>
@@ -3185,14 +3185,930 @@
         </p:nvPicPr>
         <p:blipFill>
           <a:blip r:embed="rId5"/>
+          <a:srcRect l="63182" t="-16098" r="603" b="80883"/>
           <a:stretch>
             <a:fillRect/>
           </a:stretch>
         </p:blipFill>
         <p:spPr>
           <a:xfrm>
-            <a:off x="31036889" y="7424985"/>
-            <a:ext cx="10147285" cy="7470263"/>
+            <a:off x="29616362" y="23491577"/>
+            <a:ext cx="5193818" cy="3718036"/>
+          </a:xfrm>
+          <a:prstGeom prst="rect">
+            <a:avLst/>
+          </a:prstGeom>
+        </p:spPr>
+      </p:pic>
+      <p:sp>
+        <p:nvSpPr>
+          <p:cNvPr id="4" name="TextBox 3">
+            <a:extLst>
+              <a:ext uri="{FF2B5EF4-FFF2-40B4-BE49-F238E27FC236}">
+                <a16:creationId xmlns:a16="http://schemas.microsoft.com/office/drawing/2014/main" id="{A5061EAD-0D27-4615-7CD9-87D6C112CB87}"/>
+              </a:ext>
+            </a:extLst>
+          </p:cNvPr>
+          <p:cNvSpPr txBox="1"/>
+          <p:nvPr/>
+        </p:nvSpPr>
+        <p:spPr>
+          <a:xfrm>
+            <a:off x="919074" y="6054298"/>
+            <a:ext cx="12502507" cy="10402848"/>
+          </a:xfrm>
+          <a:prstGeom prst="rect">
+            <a:avLst/>
+          </a:prstGeom>
+          <a:noFill/>
+        </p:spPr>
+        <p:txBody>
+          <a:bodyPr wrap="square" rtlCol="0">
+            <a:spAutoFit/>
+          </a:bodyPr>
+          <a:lstStyle/>
+          <a:p>
+            <a:pPr>
+              <a:spcAft>
+                <a:spcPts val="1200"/>
+              </a:spcAft>
+            </a:pPr>
+            <a:r>
+              <a:rPr lang="en-US" sz="4800" b="1" dirty="0"/>
+              <a:t>Abstract</a:t>
+            </a:r>
+          </a:p>
+          <a:p>
+            <a:pPr marL="685800" indent="-685800">
+              <a:buFont typeface="Arial" panose="020B0604020202020204" pitchFamily="34" charset="0"/>
+              <a:buChar char="•"/>
+            </a:pPr>
+            <a:r>
+              <a:rPr lang="en-US" sz="3400" dirty="0"/>
+              <a:t>We construct a data-driven global mean sea-level (GMSL) forecast model by calibrating reduced physical models for individual sea-level contributors against decades-long independent observational records. </a:t>
+            </a:r>
+          </a:p>
+          <a:p>
+            <a:pPr marL="685800" indent="-685800">
+              <a:buFont typeface="Arial" panose="020B0604020202020204" pitchFamily="34" charset="0"/>
+              <a:buChar char="•"/>
+            </a:pPr>
+            <a:r>
+              <a:rPr lang="en-US" sz="3400" dirty="0"/>
+              <a:t>When forced with observed surface temperatures, the calibrated components sum to match observed GMSL within error back to 1950.</a:t>
+            </a:r>
+          </a:p>
+          <a:p>
+            <a:pPr marL="685800" indent="-685800">
+              <a:buFont typeface="Arial" panose="020B0604020202020204" pitchFamily="34" charset="0"/>
+              <a:buChar char="•"/>
+            </a:pPr>
+            <a:r>
+              <a:rPr lang="en-US" sz="3400" dirty="0"/>
+              <a:t>Our forecasts show a 73% probability of GMSLR exceeding 1 meter (pre-industrial), and 10% of exceeding 2 meters, by the end of the century.</a:t>
+            </a:r>
+          </a:p>
+          <a:p>
+            <a:pPr marL="685800" indent="-685800">
+              <a:buFont typeface="Arial" panose="020B0604020202020204" pitchFamily="34" charset="0"/>
+              <a:buChar char="•"/>
+            </a:pPr>
+            <a:r>
+              <a:rPr lang="en-US" sz="3400" dirty="0"/>
+              <a:t>The dynamics of West Antarctic glaciers account for &gt;90% of the forecast uncertainty.</a:t>
+            </a:r>
+          </a:p>
+          <a:p>
+            <a:pPr marL="685800" indent="-685800">
+              <a:buFont typeface="Arial" panose="020B0604020202020204" pitchFamily="34" charset="0"/>
+              <a:buChar char="•"/>
+            </a:pPr>
+            <a:r>
+              <a:rPr lang="en-US" sz="3400" dirty="0"/>
+              <a:t>Reveals orthogonal dimensions of sea-level risk: emissions reduction decreases median projections related to the predictable, temperature-sensitive components, but leaves the WAIS-driven, high-risk tail of the distribution largely unchanged.</a:t>
+            </a:r>
+          </a:p>
+          <a:p>
+            <a:pPr marL="685800" indent="-685800">
+              <a:buFont typeface="Arial" panose="020B0604020202020204" pitchFamily="34" charset="0"/>
+              <a:buChar char="•"/>
+            </a:pPr>
+            <a:r>
+              <a:rPr lang="en-US" sz="3400" dirty="0">
+                <a:solidFill>
+                  <a:schemeClr val="bg2">
+                    <a:lumMod val="50000"/>
+                  </a:schemeClr>
+                </a:solidFill>
+              </a:rPr>
+              <a:t>(Note: SSP1-2.6, SSP2-4.5, SSP3-7.0 map to 2 ℃ , 3 ℃, 4 ℃) </a:t>
+            </a:r>
+          </a:p>
+        </p:txBody>
+      </p:sp>
+      <p:sp>
+        <p:nvSpPr>
+          <p:cNvPr id="6" name="TextBox 5">
+            <a:extLst>
+              <a:ext uri="{FF2B5EF4-FFF2-40B4-BE49-F238E27FC236}">
+                <a16:creationId xmlns:a16="http://schemas.microsoft.com/office/drawing/2014/main" id="{C5DBB16F-720C-56AA-58A8-4576EB6148A1}"/>
+              </a:ext>
+            </a:extLst>
+          </p:cNvPr>
+          <p:cNvSpPr txBox="1"/>
+          <p:nvPr/>
+        </p:nvSpPr>
+        <p:spPr>
+          <a:xfrm>
+            <a:off x="919074" y="17078511"/>
+            <a:ext cx="12111125" cy="830997"/>
+          </a:xfrm>
+          <a:prstGeom prst="rect">
+            <a:avLst/>
+          </a:prstGeom>
+          <a:noFill/>
+        </p:spPr>
+        <p:txBody>
+          <a:bodyPr wrap="square" rtlCol="0">
+            <a:spAutoFit/>
+          </a:bodyPr>
+          <a:lstStyle/>
+          <a:p>
+            <a:r>
+              <a:rPr lang="en-US" sz="4800" b="1" dirty="0"/>
+              <a:t>Global data and model performance</a:t>
+            </a:r>
+            <a:endParaRPr lang="en-US" sz="4800" dirty="0"/>
+          </a:p>
+        </p:txBody>
+      </p:sp>
+      <p:sp>
+        <p:nvSpPr>
+          <p:cNvPr id="8" name="TextBox 7">
+            <a:extLst>
+              <a:ext uri="{FF2B5EF4-FFF2-40B4-BE49-F238E27FC236}">
+                <a16:creationId xmlns:a16="http://schemas.microsoft.com/office/drawing/2014/main" id="{897FE8BD-CEDD-1726-877B-A443ED2169D5}"/>
+              </a:ext>
+            </a:extLst>
+          </p:cNvPr>
+          <p:cNvSpPr txBox="1"/>
+          <p:nvPr/>
+        </p:nvSpPr>
+        <p:spPr>
+          <a:xfrm>
+            <a:off x="1080271" y="18062634"/>
+            <a:ext cx="12502507" cy="3200876"/>
+          </a:xfrm>
+          <a:prstGeom prst="rect">
+            <a:avLst/>
+          </a:prstGeom>
+          <a:noFill/>
+        </p:spPr>
+        <p:txBody>
+          <a:bodyPr wrap="square" rtlCol="0">
+            <a:spAutoFit/>
+          </a:bodyPr>
+          <a:lstStyle/>
+          <a:p>
+            <a:r>
+              <a:rPr lang="en-US" sz="3400" dirty="0"/>
+              <a:t>Key takeaways: </a:t>
+            </a:r>
+          </a:p>
+          <a:p>
+            <a:pPr marL="457200" indent="-457200">
+              <a:buFont typeface="Arial" panose="020B0604020202020204" pitchFamily="34" charset="0"/>
+              <a:buChar char="•"/>
+            </a:pPr>
+            <a:r>
+              <a:rPr lang="en-US" sz="3400" dirty="0"/>
+              <a:t>Hindcast results of our model closely match independent observations in (a) GMSL time-series and (b) GMSL rate and temperature anomaly  </a:t>
+            </a:r>
+          </a:p>
+          <a:p>
+            <a:pPr marL="457200" indent="-457200">
+              <a:buFont typeface="Arial" panose="020B0604020202020204" pitchFamily="34" charset="0"/>
+              <a:buChar char="•"/>
+            </a:pPr>
+            <a:r>
+              <a:rPr lang="en-US" sz="3400" dirty="0"/>
+              <a:t>Forecasts track observed trends in the first decade</a:t>
+            </a:r>
+          </a:p>
+          <a:p>
+            <a:pPr marL="685800" indent="-685800">
+              <a:buFont typeface="Arial" panose="020B0604020202020204" pitchFamily="34" charset="0"/>
+              <a:buChar char="•"/>
+            </a:pPr>
+            <a:endParaRPr lang="en-US" sz="3200" dirty="0">
+              <a:solidFill>
+                <a:schemeClr val="bg2">
+                  <a:lumMod val="50000"/>
+                </a:schemeClr>
+              </a:solidFill>
+            </a:endParaRPr>
+          </a:p>
+        </p:txBody>
+      </p:sp>
+      <p:sp>
+        <p:nvSpPr>
+          <p:cNvPr id="10" name="TextBox 9">
+            <a:extLst>
+              <a:ext uri="{FF2B5EF4-FFF2-40B4-BE49-F238E27FC236}">
+                <a16:creationId xmlns:a16="http://schemas.microsoft.com/office/drawing/2014/main" id="{7A3D8956-56BE-3F7F-DC45-227A78031932}"/>
+              </a:ext>
+            </a:extLst>
+          </p:cNvPr>
+          <p:cNvSpPr txBox="1"/>
+          <p:nvPr/>
+        </p:nvSpPr>
+        <p:spPr>
+          <a:xfrm>
+            <a:off x="14051082" y="5995829"/>
+            <a:ext cx="14265911" cy="830997"/>
+          </a:xfrm>
+          <a:prstGeom prst="rect">
+            <a:avLst/>
+          </a:prstGeom>
+          <a:noFill/>
+        </p:spPr>
+        <p:txBody>
+          <a:bodyPr wrap="square" rtlCol="0">
+            <a:spAutoFit/>
+          </a:bodyPr>
+          <a:lstStyle/>
+          <a:p>
+            <a:r>
+              <a:rPr lang="en-US" sz="4800" b="1" dirty="0"/>
+              <a:t>Model components </a:t>
+            </a:r>
+            <a:r>
+              <a:rPr lang="en-US" sz="4800" dirty="0"/>
+              <a:t>(only showing most relevant)</a:t>
+            </a:r>
+          </a:p>
+        </p:txBody>
+      </p:sp>
+      <p:sp>
+        <p:nvSpPr>
+          <p:cNvPr id="12" name="TextBox 11">
+            <a:extLst>
+              <a:ext uri="{FF2B5EF4-FFF2-40B4-BE49-F238E27FC236}">
+                <a16:creationId xmlns:a16="http://schemas.microsoft.com/office/drawing/2014/main" id="{45856CA1-ADC0-20AD-34A5-6019CCF12CC2}"/>
+              </a:ext>
+            </a:extLst>
+          </p:cNvPr>
+          <p:cNvSpPr txBox="1"/>
+          <p:nvPr/>
+        </p:nvSpPr>
+        <p:spPr>
+          <a:xfrm>
+            <a:off x="14210582" y="19680698"/>
+            <a:ext cx="13713332" cy="12803505"/>
+          </a:xfrm>
+          <a:prstGeom prst="rect">
+            <a:avLst/>
+          </a:prstGeom>
+          <a:noFill/>
+        </p:spPr>
+        <p:txBody>
+          <a:bodyPr wrap="square" rtlCol="0">
+            <a:spAutoFit/>
+          </a:bodyPr>
+          <a:lstStyle/>
+          <a:p>
+            <a:endParaRPr lang="en-US" sz="3400" b="1" dirty="0"/>
+          </a:p>
+          <a:p>
+            <a:pPr marL="685800" indent="-685800">
+              <a:buFont typeface="Arial" panose="020B0604020202020204" pitchFamily="34" charset="0"/>
+              <a:buChar char="•"/>
+            </a:pPr>
+            <a:r>
+              <a:rPr lang="en-US" sz="3400" dirty="0"/>
+              <a:t>Ocean thermal expansion (thermosteric): Modeled as a two-layer energy balance, each with a variable state, relaxation time, and sensitivities. </a:t>
+            </a:r>
+          </a:p>
+          <a:p>
+            <a:pPr marL="685800" indent="-685800">
+              <a:buFont typeface="Arial" panose="020B0604020202020204" pitchFamily="34" charset="0"/>
+              <a:buChar char="•"/>
+            </a:pPr>
+            <a:endParaRPr lang="en-US" sz="3400" dirty="0"/>
+          </a:p>
+          <a:p>
+            <a:pPr marL="685800" indent="-685800">
+              <a:buFont typeface="Arial" panose="020B0604020202020204" pitchFamily="34" charset="0"/>
+              <a:buChar char="•"/>
+            </a:pPr>
+            <a:endParaRPr lang="en-US" sz="3400" dirty="0"/>
+          </a:p>
+          <a:p>
+            <a:pPr marL="685800" indent="-685800">
+              <a:buFont typeface="Arial" panose="020B0604020202020204" pitchFamily="34" charset="0"/>
+              <a:buChar char="•"/>
+            </a:pPr>
+            <a:endParaRPr lang="en-US" sz="3400" dirty="0"/>
+          </a:p>
+          <a:p>
+            <a:pPr marL="685800" indent="-685800">
+              <a:buFont typeface="Arial" panose="020B0604020202020204" pitchFamily="34" charset="0"/>
+              <a:buChar char="•"/>
+            </a:pPr>
+            <a:endParaRPr lang="en-US" sz="3400" dirty="0"/>
+          </a:p>
+          <a:p>
+            <a:endParaRPr lang="en-US" sz="3400" dirty="0"/>
+          </a:p>
+          <a:p>
+            <a:pPr marL="685800" indent="-685800">
+              <a:spcAft>
+                <a:spcPts val="1200"/>
+              </a:spcAft>
+              <a:buFont typeface="Arial" panose="020B0604020202020204" pitchFamily="34" charset="0"/>
+              <a:buChar char="•"/>
+            </a:pPr>
+            <a:r>
+              <a:rPr lang="en-US" sz="3400" dirty="0"/>
+              <a:t>Greenland glacier discharge: Modeled as an ocean-driven delay model forced by EN4 ocean temperatures in the peripheral waters surrounding Greenland. </a:t>
+            </a:r>
+          </a:p>
+          <a:p>
+            <a:pPr marL="685800" indent="-685800">
+              <a:buFont typeface="Arial" panose="020B0604020202020204" pitchFamily="34" charset="0"/>
+              <a:buChar char="•"/>
+            </a:pPr>
+            <a:endParaRPr lang="en-US" sz="3400" dirty="0"/>
+          </a:p>
+          <a:p>
+            <a:pPr marL="685800" indent="-685800">
+              <a:buFont typeface="Arial" panose="020B0604020202020204" pitchFamily="34" charset="0"/>
+              <a:buChar char="•"/>
+            </a:pPr>
+            <a:endParaRPr lang="en-US" sz="3400" dirty="0"/>
+          </a:p>
+          <a:p>
+            <a:pPr marL="685800" indent="-685800">
+              <a:buFont typeface="Arial" panose="020B0604020202020204" pitchFamily="34" charset="0"/>
+              <a:buChar char="•"/>
+            </a:pPr>
+            <a:r>
+              <a:rPr lang="en-US" sz="3400" dirty="0"/>
+              <a:t>Greenland surface mass balance (SMB): Calibrated with regional climate models due to a lack of sufficient data coverage</a:t>
+            </a:r>
+            <a:endParaRPr lang="en-US" sz="3400" dirty="0">
+              <a:solidFill>
+                <a:schemeClr val="bg2">
+                  <a:lumMod val="50000"/>
+                </a:schemeClr>
+              </a:solidFill>
+            </a:endParaRPr>
+          </a:p>
+          <a:p>
+            <a:pPr marL="685800" indent="-685800">
+              <a:buFont typeface="Arial" panose="020B0604020202020204" pitchFamily="34" charset="0"/>
+              <a:buChar char="•"/>
+            </a:pPr>
+            <a:endParaRPr lang="en-US" sz="3400" dirty="0">
+              <a:solidFill>
+                <a:schemeClr val="bg2">
+                  <a:lumMod val="50000"/>
+                </a:schemeClr>
+              </a:solidFill>
+            </a:endParaRPr>
+          </a:p>
+          <a:p>
+            <a:pPr marL="685800" indent="-685800">
+              <a:buFont typeface="Arial" panose="020B0604020202020204" pitchFamily="34" charset="0"/>
+              <a:buChar char="•"/>
+            </a:pPr>
+            <a:r>
+              <a:rPr lang="en-US" sz="3400" dirty="0"/>
+              <a:t>West Antarctic Ice Sheet (WAIS) represented by a probabilistic scenario-mixture model that accounts for the broad range of possible mass loss rates from the scientific literature.  </a:t>
+            </a:r>
+          </a:p>
+          <a:p>
+            <a:pPr marL="1143000" lvl="1" indent="-685800">
+              <a:buFont typeface="Arial" panose="020B0604020202020204" pitchFamily="34" charset="0"/>
+              <a:buChar char="•"/>
+            </a:pPr>
+            <a:r>
+              <a:rPr lang="en-US" sz="3400" dirty="0"/>
+              <a:t>`Slow WAIS’: Ice sheet continues to lose mass at the current rate and acceleration</a:t>
+            </a:r>
+          </a:p>
+          <a:p>
+            <a:pPr marL="1143000" lvl="1" indent="-685800">
+              <a:buFont typeface="Arial" panose="020B0604020202020204" pitchFamily="34" charset="0"/>
+              <a:buChar char="•"/>
+            </a:pPr>
+            <a:r>
+              <a:rPr lang="en-US" sz="3400" dirty="0"/>
+              <a:t>`Fast WAIS’: Internal feedbacks (primarily MISI) accelerate mass loss. These are taken to independent of emission scenarios.</a:t>
+            </a:r>
+          </a:p>
+        </p:txBody>
+      </p:sp>
+      <p:pic>
+        <p:nvPicPr>
+          <p:cNvPr id="17" name="Picture 16">
+            <a:extLst>
+              <a:ext uri="{FF2B5EF4-FFF2-40B4-BE49-F238E27FC236}">
+                <a16:creationId xmlns:a16="http://schemas.microsoft.com/office/drawing/2014/main" id="{EA818A1F-438D-2367-BD43-54830A9F71CF}"/>
+              </a:ext>
+            </a:extLst>
+          </p:cNvPr>
+          <p:cNvPicPr>
+            <a:picLocks noChangeAspect="1"/>
+          </p:cNvPicPr>
+          <p:nvPr/>
+        </p:nvPicPr>
+        <p:blipFill>
+          <a:blip r:embed="rId6"/>
+          <a:stretch>
+            <a:fillRect/>
+          </a:stretch>
+        </p:blipFill>
+        <p:spPr>
+          <a:xfrm>
+            <a:off x="16150479" y="26131382"/>
+            <a:ext cx="9643541" cy="732720"/>
+          </a:xfrm>
+          <a:prstGeom prst="rect">
+            <a:avLst/>
+          </a:prstGeom>
+        </p:spPr>
+      </p:pic>
+      <p:sp>
+        <p:nvSpPr>
+          <p:cNvPr id="20" name="TextBox 19">
+            <a:extLst>
+              <a:ext uri="{FF2B5EF4-FFF2-40B4-BE49-F238E27FC236}">
+                <a16:creationId xmlns:a16="http://schemas.microsoft.com/office/drawing/2014/main" id="{04194E60-E508-7EE3-4D5D-719C2AC07EC9}"/>
+              </a:ext>
+            </a:extLst>
+          </p:cNvPr>
+          <p:cNvSpPr txBox="1"/>
+          <p:nvPr/>
+        </p:nvSpPr>
+        <p:spPr>
+          <a:xfrm>
+            <a:off x="28946494" y="5995829"/>
+            <a:ext cx="14265911" cy="830997"/>
+          </a:xfrm>
+          <a:prstGeom prst="rect">
+            <a:avLst/>
+          </a:prstGeom>
+          <a:noFill/>
+        </p:spPr>
+        <p:txBody>
+          <a:bodyPr wrap="square" rtlCol="0">
+            <a:spAutoFit/>
+          </a:bodyPr>
+          <a:lstStyle/>
+          <a:p>
+            <a:r>
+              <a:rPr lang="en-US" sz="4800" b="1" dirty="0"/>
+              <a:t>Forecasts</a:t>
+            </a:r>
+            <a:endParaRPr lang="en-US" sz="4800" dirty="0"/>
+          </a:p>
+        </p:txBody>
+      </p:sp>
+      <p:pic>
+        <p:nvPicPr>
+          <p:cNvPr id="24" name="Picture 23">
+            <a:extLst>
+              <a:ext uri="{FF2B5EF4-FFF2-40B4-BE49-F238E27FC236}">
+                <a16:creationId xmlns:a16="http://schemas.microsoft.com/office/drawing/2014/main" id="{1559C98B-3DA1-B513-17E1-C952ED9542F4}"/>
+              </a:ext>
+            </a:extLst>
+          </p:cNvPr>
+          <p:cNvPicPr>
+            <a:picLocks noChangeAspect="1"/>
+          </p:cNvPicPr>
+          <p:nvPr/>
+        </p:nvPicPr>
+        <p:blipFill>
+          <a:blip r:embed="rId7"/>
+          <a:srcRect l="29928" r="29927" b="30825"/>
+          <a:stretch>
+            <a:fillRect/>
+          </a:stretch>
+        </p:blipFill>
+        <p:spPr>
+          <a:xfrm>
+            <a:off x="6387180" y="1245267"/>
+            <a:ext cx="2573940" cy="2494793"/>
+          </a:xfrm>
+          <a:prstGeom prst="rect">
+            <a:avLst/>
+          </a:prstGeom>
+        </p:spPr>
+      </p:pic>
+      <p:pic>
+        <p:nvPicPr>
+          <p:cNvPr id="26" name="Picture 25">
+            <a:extLst>
+              <a:ext uri="{FF2B5EF4-FFF2-40B4-BE49-F238E27FC236}">
+                <a16:creationId xmlns:a16="http://schemas.microsoft.com/office/drawing/2014/main" id="{5B2D47DF-4C1B-2D2F-DC8C-7D1F152EF8BD}"/>
+              </a:ext>
+            </a:extLst>
+          </p:cNvPr>
+          <p:cNvPicPr>
+            <a:picLocks noChangeAspect="1"/>
+          </p:cNvPicPr>
+          <p:nvPr/>
+        </p:nvPicPr>
+        <p:blipFill>
+          <a:blip r:embed="rId8"/>
+          <a:stretch>
+            <a:fillRect/>
+          </a:stretch>
+        </p:blipFill>
+        <p:spPr>
+          <a:xfrm>
+            <a:off x="919074" y="1827570"/>
+            <a:ext cx="4958798" cy="1197912"/>
+          </a:xfrm>
+          <a:prstGeom prst="rect">
+            <a:avLst/>
+          </a:prstGeom>
+        </p:spPr>
+      </p:pic>
+      <p:pic>
+        <p:nvPicPr>
+          <p:cNvPr id="28" name="Picture 27">
+            <a:extLst>
+              <a:ext uri="{FF2B5EF4-FFF2-40B4-BE49-F238E27FC236}">
+                <a16:creationId xmlns:a16="http://schemas.microsoft.com/office/drawing/2014/main" id="{C01A9CDB-CA64-7D1E-0CB7-7072ACBDF975}"/>
+              </a:ext>
+            </a:extLst>
+          </p:cNvPr>
+          <p:cNvPicPr>
+            <a:picLocks noChangeAspect="1"/>
+          </p:cNvPicPr>
+          <p:nvPr/>
+        </p:nvPicPr>
+        <p:blipFill>
+          <a:blip r:embed="rId9"/>
+          <a:stretch>
+            <a:fillRect/>
+          </a:stretch>
+        </p:blipFill>
+        <p:spPr>
+          <a:xfrm>
+            <a:off x="34730875" y="1515547"/>
+            <a:ext cx="5439557" cy="2156140"/>
+          </a:xfrm>
+          <a:prstGeom prst="rect">
+            <a:avLst/>
+          </a:prstGeom>
+        </p:spPr>
+      </p:pic>
+      <p:sp>
+        <p:nvSpPr>
+          <p:cNvPr id="30" name="TextBox 29">
+            <a:extLst>
+              <a:ext uri="{FF2B5EF4-FFF2-40B4-BE49-F238E27FC236}">
+                <a16:creationId xmlns:a16="http://schemas.microsoft.com/office/drawing/2014/main" id="{C3FBE2B9-F4DB-E7E5-52DB-BC89C7CA8456}"/>
+              </a:ext>
+            </a:extLst>
+          </p:cNvPr>
+          <p:cNvSpPr txBox="1"/>
+          <p:nvPr/>
+        </p:nvSpPr>
+        <p:spPr>
+          <a:xfrm>
+            <a:off x="29355838" y="27062617"/>
+            <a:ext cx="12502507" cy="5693866"/>
+          </a:xfrm>
+          <a:prstGeom prst="rect">
+            <a:avLst/>
+          </a:prstGeom>
+          <a:noFill/>
+        </p:spPr>
+        <p:txBody>
+          <a:bodyPr wrap="square" rtlCol="0">
+            <a:spAutoFit/>
+          </a:bodyPr>
+          <a:lstStyle/>
+          <a:p>
+            <a:pPr>
+              <a:spcAft>
+                <a:spcPts val="1200"/>
+              </a:spcAft>
+            </a:pPr>
+            <a:r>
+              <a:rPr lang="en-US" sz="4800" b="1" dirty="0"/>
+              <a:t>Take-aways</a:t>
+            </a:r>
+          </a:p>
+          <a:p>
+            <a:pPr marL="685800" indent="-685800">
+              <a:buFont typeface="Arial" panose="020B0604020202020204" pitchFamily="34" charset="0"/>
+              <a:buChar char="•"/>
+            </a:pPr>
+            <a:r>
+              <a:rPr lang="en-US" sz="3400" dirty="0"/>
+              <a:t>Virtually all uncertainty is in West Antarctica </a:t>
+            </a:r>
+          </a:p>
+          <a:p>
+            <a:pPr marL="685800" indent="-685800">
+              <a:buFont typeface="Arial" panose="020B0604020202020204" pitchFamily="34" charset="0"/>
+              <a:buChar char="•"/>
+            </a:pPr>
+            <a:r>
+              <a:rPr lang="en-US" sz="3400" dirty="0"/>
+              <a:t>Other sea level contributors are predictable</a:t>
+            </a:r>
+          </a:p>
+          <a:p>
+            <a:pPr marL="685800" indent="-685800">
+              <a:buFont typeface="Arial" panose="020B0604020202020204" pitchFamily="34" charset="0"/>
+              <a:buChar char="•"/>
+            </a:pPr>
+            <a:r>
+              <a:rPr lang="en-US" sz="3400" dirty="0"/>
+              <a:t>Orthogonal risks: </a:t>
+            </a:r>
+          </a:p>
+          <a:p>
+            <a:pPr marL="1143000" lvl="1" indent="-685800">
+              <a:buFont typeface="Arial" panose="020B0604020202020204" pitchFamily="34" charset="0"/>
+              <a:buChar char="•"/>
+            </a:pPr>
+            <a:r>
+              <a:rPr lang="en-US" sz="3400" dirty="0"/>
+              <a:t>Cutting emissions reduces the predictable, temperature-sensitive components </a:t>
+            </a:r>
+          </a:p>
+          <a:p>
+            <a:pPr marL="1143000" lvl="1" indent="-685800">
+              <a:buFont typeface="Arial" panose="020B0604020202020204" pitchFamily="34" charset="0"/>
+              <a:buChar char="•"/>
+            </a:pPr>
+            <a:r>
+              <a:rPr lang="en-US" sz="3400" dirty="0"/>
+              <a:t>WAIS contribution is largely insensitive to emission reductions</a:t>
+            </a:r>
+          </a:p>
+          <a:p>
+            <a:pPr marL="685800" indent="-685800">
+              <a:buFont typeface="Arial" panose="020B0604020202020204" pitchFamily="34" charset="0"/>
+              <a:buChar char="•"/>
+            </a:pPr>
+            <a:r>
+              <a:rPr lang="en-US" sz="3400" dirty="0"/>
+              <a:t>Most valuable question: How fast will WAIS lose mass?</a:t>
+            </a:r>
+          </a:p>
+          <a:p>
+            <a:pPr marL="685800" indent="-685800">
+              <a:buFont typeface="Arial" panose="020B0604020202020204" pitchFamily="34" charset="0"/>
+              <a:buChar char="•"/>
+            </a:pPr>
+            <a:endParaRPr lang="en-US" sz="3400" dirty="0">
+              <a:solidFill>
+                <a:schemeClr val="bg2">
+                  <a:lumMod val="50000"/>
+                </a:schemeClr>
+              </a:solidFill>
+            </a:endParaRPr>
+          </a:p>
+        </p:txBody>
+      </p:sp>
+      <p:cxnSp>
+        <p:nvCxnSpPr>
+          <p:cNvPr id="33" name="Straight Connector 32">
+            <a:extLst>
+              <a:ext uri="{FF2B5EF4-FFF2-40B4-BE49-F238E27FC236}">
+                <a16:creationId xmlns:a16="http://schemas.microsoft.com/office/drawing/2014/main" id="{63CFFFC9-A64F-5F66-ACBC-6645EC0F87B3}"/>
+              </a:ext>
+            </a:extLst>
+          </p:cNvPr>
+          <p:cNvCxnSpPr>
+            <a:cxnSpLocks/>
+          </p:cNvCxnSpPr>
+          <p:nvPr/>
+        </p:nvCxnSpPr>
+        <p:spPr>
+          <a:xfrm>
+            <a:off x="919074" y="5283200"/>
+            <a:ext cx="40758489" cy="0"/>
+          </a:xfrm>
+          <a:prstGeom prst="line">
+            <a:avLst/>
+          </a:prstGeom>
+          <a:ln w="57150">
+            <a:solidFill>
+              <a:srgbClr val="FF6C0C"/>
+            </a:solidFill>
+          </a:ln>
+        </p:spPr>
+        <p:style>
+          <a:lnRef idx="2">
+            <a:schemeClr val="accent1"/>
+          </a:lnRef>
+          <a:fillRef idx="0">
+            <a:schemeClr val="accent1"/>
+          </a:fillRef>
+          <a:effectRef idx="1">
+            <a:schemeClr val="accent1"/>
+          </a:effectRef>
+          <a:fontRef idx="minor">
+            <a:schemeClr val="tx1"/>
+          </a:fontRef>
+        </p:style>
+      </p:cxnSp>
+      <p:pic>
+        <p:nvPicPr>
+          <p:cNvPr id="37" name="Picture 36">
+            <a:extLst>
+              <a:ext uri="{FF2B5EF4-FFF2-40B4-BE49-F238E27FC236}">
+                <a16:creationId xmlns:a16="http://schemas.microsoft.com/office/drawing/2014/main" id="{0C7E0EBC-D3B7-DEDE-41B3-BA2F2B99B8C0}"/>
+              </a:ext>
+            </a:extLst>
+          </p:cNvPr>
+          <p:cNvPicPr>
+            <a:picLocks noChangeAspect="1"/>
+          </p:cNvPicPr>
+          <p:nvPr/>
+        </p:nvPicPr>
+        <p:blipFill>
+          <a:blip r:embed="rId10"/>
+          <a:stretch>
+            <a:fillRect/>
+          </a:stretch>
+        </p:blipFill>
+        <p:spPr>
+          <a:xfrm>
+            <a:off x="15481839" y="22243743"/>
+            <a:ext cx="5490410" cy="1792787"/>
+          </a:xfrm>
+          <a:prstGeom prst="rect">
+            <a:avLst/>
+          </a:prstGeom>
+        </p:spPr>
+      </p:pic>
+      <p:pic>
+        <p:nvPicPr>
+          <p:cNvPr id="38" name="Picture 37">
+            <a:extLst>
+              <a:ext uri="{FF2B5EF4-FFF2-40B4-BE49-F238E27FC236}">
+                <a16:creationId xmlns:a16="http://schemas.microsoft.com/office/drawing/2014/main" id="{CF7D3B8E-62C0-CF11-6754-8B9F1B6E27D7}"/>
+              </a:ext>
+            </a:extLst>
+          </p:cNvPr>
+          <p:cNvPicPr>
+            <a:picLocks noChangeAspect="1"/>
+          </p:cNvPicPr>
+          <p:nvPr/>
+        </p:nvPicPr>
+        <p:blipFill>
+          <a:blip r:embed="rId11"/>
+          <a:stretch>
+            <a:fillRect/>
+          </a:stretch>
+        </p:blipFill>
+        <p:spPr>
+          <a:xfrm>
+            <a:off x="22082371" y="22234999"/>
+            <a:ext cx="5571982" cy="1792787"/>
+          </a:xfrm>
+          <a:prstGeom prst="rect">
+            <a:avLst/>
+          </a:prstGeom>
+        </p:spPr>
+      </p:pic>
+      <p:pic>
+        <p:nvPicPr>
+          <p:cNvPr id="40" name="Picture 39">
+            <a:extLst>
+              <a:ext uri="{FF2B5EF4-FFF2-40B4-BE49-F238E27FC236}">
+                <a16:creationId xmlns:a16="http://schemas.microsoft.com/office/drawing/2014/main" id="{813BD519-9C2F-D2A1-A541-F33205D2D0EF}"/>
+              </a:ext>
+            </a:extLst>
+          </p:cNvPr>
+          <p:cNvPicPr>
+            <a:picLocks noChangeAspect="1"/>
+          </p:cNvPicPr>
+          <p:nvPr/>
+        </p:nvPicPr>
+        <p:blipFill>
+          <a:blip r:embed="rId5"/>
+          <a:srcRect l="60363" t="18476" r="603" b="49221"/>
+          <a:stretch>
+            <a:fillRect/>
+          </a:stretch>
+        </p:blipFill>
+        <p:spPr>
+          <a:xfrm>
+            <a:off x="35607091" y="23652053"/>
+            <a:ext cx="5598114" cy="3410564"/>
+          </a:xfrm>
+          <a:prstGeom prst="rect">
+            <a:avLst/>
+          </a:prstGeom>
+        </p:spPr>
+      </p:pic>
+      <p:sp>
+        <p:nvSpPr>
+          <p:cNvPr id="41" name="TextBox 40">
+            <a:extLst>
+              <a:ext uri="{FF2B5EF4-FFF2-40B4-BE49-F238E27FC236}">
+                <a16:creationId xmlns:a16="http://schemas.microsoft.com/office/drawing/2014/main" id="{C7E6C7A9-D882-1879-4C05-1D3CFA2F4AFB}"/>
+              </a:ext>
+            </a:extLst>
+          </p:cNvPr>
+          <p:cNvSpPr txBox="1"/>
+          <p:nvPr/>
+        </p:nvSpPr>
+        <p:spPr>
+          <a:xfrm>
+            <a:off x="29195171" y="23499859"/>
+            <a:ext cx="6600532" cy="1661993"/>
+          </a:xfrm>
+          <a:prstGeom prst="rect">
+            <a:avLst/>
+          </a:prstGeom>
+          <a:noFill/>
+        </p:spPr>
+        <p:txBody>
+          <a:bodyPr wrap="square" rtlCol="0">
+            <a:spAutoFit/>
+          </a:bodyPr>
+          <a:lstStyle/>
+          <a:p>
+            <a:r>
+              <a:rPr lang="en-US" sz="3400" dirty="0"/>
+              <a:t>Internal dynamical feedbacks in WAIS make variances of all other sea-level contributors negligible </a:t>
+            </a:r>
+          </a:p>
+        </p:txBody>
+      </p:sp>
+      <p:sp>
+        <p:nvSpPr>
+          <p:cNvPr id="42" name="TextBox 41">
+            <a:extLst>
+              <a:ext uri="{FF2B5EF4-FFF2-40B4-BE49-F238E27FC236}">
+                <a16:creationId xmlns:a16="http://schemas.microsoft.com/office/drawing/2014/main" id="{1BE94543-D15C-7FD5-87D3-576C6D7F3F04}"/>
+              </a:ext>
+            </a:extLst>
+          </p:cNvPr>
+          <p:cNvSpPr txBox="1"/>
+          <p:nvPr/>
+        </p:nvSpPr>
+        <p:spPr>
+          <a:xfrm>
+            <a:off x="28946494" y="22740818"/>
+            <a:ext cx="14265911" cy="830997"/>
+          </a:xfrm>
+          <a:prstGeom prst="rect">
+            <a:avLst/>
+          </a:prstGeom>
+          <a:noFill/>
+        </p:spPr>
+        <p:txBody>
+          <a:bodyPr wrap="square" rtlCol="0">
+            <a:spAutoFit/>
+          </a:bodyPr>
+          <a:lstStyle/>
+          <a:p>
+            <a:r>
+              <a:rPr lang="en-US" sz="4800" b="1" dirty="0"/>
+              <a:t>Variance decomposition</a:t>
+            </a:r>
+            <a:endParaRPr lang="en-US" sz="4800" dirty="0"/>
+          </a:p>
+        </p:txBody>
+      </p:sp>
+      <p:pic>
+        <p:nvPicPr>
+          <p:cNvPr id="43" name="Picture 42">
+            <a:extLst>
+              <a:ext uri="{FF2B5EF4-FFF2-40B4-BE49-F238E27FC236}">
+                <a16:creationId xmlns:a16="http://schemas.microsoft.com/office/drawing/2014/main" id="{E0A727A8-3779-8811-B0A8-089A1EE7B5B4}"/>
+              </a:ext>
+            </a:extLst>
+          </p:cNvPr>
+          <p:cNvPicPr>
+            <a:picLocks noChangeAspect="1"/>
+          </p:cNvPicPr>
+          <p:nvPr/>
+        </p:nvPicPr>
+        <p:blipFill>
+          <a:blip r:embed="rId5"/>
+          <a:srcRect l="63182" t="-16098" r="603" b="97034"/>
+          <a:stretch>
+            <a:fillRect/>
+          </a:stretch>
+        </p:blipFill>
+        <p:spPr>
+          <a:xfrm>
+            <a:off x="35959654" y="21639299"/>
+            <a:ext cx="5193818" cy="2012754"/>
           </a:xfrm>
           <a:prstGeom prst="rect">
             <a:avLst/>

</xml_diff>